<commit_message>
Enhance WBGT CrewSafe SG proposal with lightning risk integration and update related documentation
</commit_message>
<xml_diff>
--- a/proposal-deliverables/WBGT-CrewSafe-SG-Proposal.pptx
+++ b/proposal-deliverables/WBGT-CrewSafe-SG-Proposal.pptx
@@ -3642,7 +3642,7 @@
                 </a:solidFill>
                 <a:latin typeface="Calibri"/>
               </a:rPr>
-              <a:t>WBGT CrewSafe SG turns Singapore's public NEA WBGT data into timely, MOM-aligned rest, hydration and task decisions for crews (landscaping, estate &amp; campus maintenance, event setup) that refer to myENV instead of an on-site meter. A guarded AI agent drafts a plan from deterministic policy rules; the supervisor approves it; workers receive and acknowledge it on mobile — every step recorded end-to-end.</a:t>
+              <a:t>WBGT CrewSafe SG turns Singapore's public NEA WBGT data into timely, MOM-aligned rest, hydration and task decisions for crews (landscaping, estate &amp; campus maintenance, event setup) that refer to myENV instead of an on-site meter. NEA lightning-strike observations sit above the WBGT reading as an overriding stop-work hazard. A guarded AI agent drafts a plan from deterministic policy rules; the supervisor approves it; workers receive and acknowledge it on mobile — every step recorded end-to-end.</a:t>
             </a:r>
           </a:p>
         </p:txBody>
@@ -4193,8 +4193,8 @@
         </p:blipFill>
         <p:spPr>
           <a:xfrm>
-            <a:off x="7690519" y="2724912"/>
-            <a:ext cx="3117272" cy="3703320"/>
+            <a:off x="7878265" y="2724912"/>
+            <a:ext cx="2741780" cy="3703320"/>
           </a:xfrm>
           <a:prstGeom prst="rect">
             <a:avLst/>
@@ -4536,7 +4536,7 @@
                 </a:solidFill>
                 <a:latin typeface="Calibri"/>
               </a:rPr>
-              <a:t>PRIORITISED PRODUCT BACKLOG   (extract — full 18-story backlog in the accompanying workbook)</a:t>
+              <a:t>PRIORITISED PRODUCT BACKLOG   (extract — full 19-story backlog in the accompanying workbook)</a:t>
             </a:r>
           </a:p>
         </p:txBody>
@@ -5595,7 +5595,7 @@
                 </a:solidFill>
                 <a:latin typeface="Calibri"/>
               </a:rPr>
-              <a:t>Forecast 30 / 60-min WBGT</a:t>
+              <a:t>Lightning stop-work warning above WBGT</a:t>
             </a:r>
           </a:p>
         </p:txBody>
@@ -5640,7 +5640,7 @@
                 </a:solidFill>
                 <a:latin typeface="Calibri"/>
               </a:rPr>
-              <a:t>Python · FastAPI · scikit-learn / XGBoost</a:t>
+              <a:t>Spring Boot · NEA lightning API · React / React Native</a:t>
             </a:r>
           </a:p>
         </p:txBody>
@@ -5685,7 +5685,7 @@
                 </a:solidFill>
                 <a:latin typeface="Calibri"/>
               </a:rPr>
-              <a:t>8</a:t>
+              <a:t>5</a:t>
             </a:r>
           </a:p>
         </p:txBody>
@@ -5730,7 +5730,7 @@
                 </a:solidFill>
                 <a:latin typeface="Calibri"/>
               </a:rPr>
-              <a:t>2</a:t>
+              <a:t>1</a:t>
             </a:r>
           </a:p>
         </p:txBody>
@@ -5918,7 +5918,7 @@
                 </a:solidFill>
                 <a:latin typeface="Calibri"/>
               </a:rPr>
-              <a:t>Evaluate deterministic heat policy</a:t>
+              <a:t>Forecast 30 / 60-min WBGT</a:t>
             </a:r>
           </a:p>
         </p:txBody>
@@ -5963,7 +5963,7 @@
                 </a:solidFill>
                 <a:latin typeface="Calibri"/>
               </a:rPr>
-              <a:t>Java 21 rules engine · PostgreSQL config</a:t>
+              <a:t>Python · FastAPI · scikit-learn / XGBoost</a:t>
             </a:r>
           </a:p>
         </p:txBody>
@@ -6241,7 +6241,7 @@
                 </a:solidFill>
                 <a:latin typeface="Calibri"/>
               </a:rPr>
-              <a:t>Explainable agent draft plan</a:t>
+              <a:t>Evaluate deterministic heat policy</a:t>
             </a:r>
           </a:p>
         </p:txBody>
@@ -6286,7 +6286,7 @@
                 </a:solidFill>
                 <a:latin typeface="Calibri"/>
               </a:rPr>
-              <a:t>Tool-calling LLM · JSON-schema guarded tools</a:t>
+              <a:t>Java 21 rules engine · PostgreSQL config</a:t>
             </a:r>
           </a:p>
         </p:txBody>
@@ -6564,7 +6564,7 @@
                 </a:solidFill>
                 <a:latin typeface="Calibri"/>
               </a:rPr>
-              <a:t>Dispatch &amp; acknowledge worker action</a:t>
+              <a:t>Explainable agent draft plan</a:t>
             </a:r>
           </a:p>
         </p:txBody>
@@ -6609,7 +6609,7 @@
                 </a:solidFill>
                 <a:latin typeface="Calibri"/>
               </a:rPr>
-              <a:t>React Native · Spring Boot · idempotency</a:t>
+              <a:t>Tool-calling LLM · JSON-schema guarded tools</a:t>
             </a:r>
           </a:p>
         </p:txBody>
@@ -6887,7 +6887,7 @@
                 </a:solidFill>
                 <a:latin typeface="Calibri"/>
               </a:rPr>
-              <a:t>Compliance &amp; response-time dashboards</a:t>
+              <a:t>Dispatch &amp; acknowledge worker action</a:t>
             </a:r>
           </a:p>
         </p:txBody>
@@ -6932,7 +6932,7 @@
                 </a:solidFill>
                 <a:latin typeface="Calibri"/>
               </a:rPr>
-              <a:t>React · Chart.js · backend aggregation</a:t>
+              <a:t>React Native · Spring Boot · idempotency</a:t>
             </a:r>
           </a:p>
         </p:txBody>
@@ -7022,7 +7022,7 @@
                 </a:solidFill>
                 <a:latin typeface="Calibri"/>
               </a:rPr>
-              <a:t>3</a:t>
+              <a:t>2</a:t>
             </a:r>
           </a:p>
         </p:txBody>
@@ -7210,7 +7210,7 @@
                 </a:solidFill>
                 <a:latin typeface="Calibri"/>
               </a:rPr>
-              <a:t>Export audit timeline</a:t>
+              <a:t>Compliance &amp; response-time dashboards</a:t>
             </a:r>
           </a:p>
         </p:txBody>
@@ -7255,7 +7255,7 @@
                 </a:solidFill>
                 <a:latin typeface="Calibri"/>
               </a:rPr>
-              <a:t>Backend CSV / PDF · append-only audit</a:t>
+              <a:t>React · Chart.js · backend aggregation</a:t>
             </a:r>
           </a:p>
         </p:txBody>
@@ -7300,7 +7300,7 @@
                 </a:solidFill>
                 <a:latin typeface="Calibri"/>
               </a:rPr>
-              <a:t>5</a:t>
+              <a:t>8</a:t>
             </a:r>
           </a:p>
         </p:txBody>
@@ -7533,7 +7533,7 @@
                 </a:solidFill>
                 <a:latin typeface="Calibri"/>
               </a:rPr>
-              <a:t>Safe degraded (NEA / ML / LLM) mode</a:t>
+              <a:t>Export audit timeline</a:t>
             </a:r>
           </a:p>
         </p:txBody>
@@ -7578,7 +7578,7 @@
                 </a:solidFill>
                 <a:latin typeface="Calibri"/>
               </a:rPr>
-              <a:t>Fallback adapters · persistence forecast</a:t>
+              <a:t>Backend CSV / PDF · append-only audit</a:t>
             </a:r>
           </a:p>
         </p:txBody>
@@ -7623,7 +7623,7 @@
                 </a:solidFill>
                 <a:latin typeface="Calibri"/>
               </a:rPr>
-              <a:t>8</a:t>
+              <a:t>5</a:t>
             </a:r>
           </a:p>
         </p:txBody>
@@ -7719,13 +7719,336 @@
       </p:sp>
       <p:sp>
         <p:nvSpPr>
-          <p:cNvPr id="78" name="Rounded Rectangle 77"/>
+          <p:cNvPr id="78" name="Rectangle 77"/>
           <p:cNvSpPr/>
           <p:nvPr/>
         </p:nvSpPr>
         <p:spPr>
           <a:xfrm>
-            <a:off x="502920" y="4864607"/>
+            <a:off x="502920" y="4736592"/>
+            <a:ext cx="7452360" cy="327355"/>
+          </a:xfrm>
+          <a:prstGeom prst="rect">
+            <a:avLst/>
+          </a:prstGeom>
+          <a:solidFill>
+            <a:srgbClr val="F5F8FC"/>
+          </a:solidFill>
+          <a:ln>
+            <a:noFill/>
+          </a:ln>
+          <a:effectLst/>
+        </p:spPr>
+        <p:style>
+          <a:lnRef idx="1">
+            <a:schemeClr val="accent1"/>
+          </a:lnRef>
+          <a:fillRef idx="3">
+            <a:schemeClr val="accent1"/>
+          </a:fillRef>
+          <a:effectRef idx="2">
+            <a:schemeClr val="accent1"/>
+          </a:effectRef>
+          <a:fontRef idx="minor">
+            <a:schemeClr val="lt1"/>
+          </a:fontRef>
+        </p:style>
+        <p:txBody>
+          <a:bodyPr rtlCol="0" anchor="ctr"/>
+          <a:lstStyle/>
+          <a:p>
+            <a:pPr algn="ctr"/>
+          </a:p>
+        </p:txBody>
+      </p:sp>
+      <p:sp>
+        <p:nvSpPr>
+          <p:cNvPr id="79" name="Rounded Rectangle 78"/>
+          <p:cNvSpPr/>
+          <p:nvPr/>
+        </p:nvSpPr>
+        <p:spPr>
+          <a:xfrm>
+            <a:off x="594360" y="4786883"/>
+            <a:ext cx="479552" cy="226771"/>
+          </a:xfrm>
+          <a:prstGeom prst="roundRect">
+            <a:avLst>
+              <a:gd name="adj" fmla="val 50000"/>
+            </a:avLst>
+          </a:prstGeom>
+          <a:solidFill>
+            <a:srgbClr val="E7F3EC"/>
+          </a:solidFill>
+          <a:ln>
+            <a:noFill/>
+          </a:ln>
+          <a:effectLst/>
+        </p:spPr>
+        <p:style>
+          <a:lnRef idx="1">
+            <a:schemeClr val="accent1"/>
+          </a:lnRef>
+          <a:fillRef idx="3">
+            <a:schemeClr val="accent1"/>
+          </a:fillRef>
+          <a:effectRef idx="2">
+            <a:schemeClr val="accent1"/>
+          </a:effectRef>
+          <a:fontRef idx="minor">
+            <a:schemeClr val="lt1"/>
+          </a:fontRef>
+        </p:style>
+        <p:txBody>
+          <a:bodyPr rtlCol="0" anchor="ctr" wrap="none" lIns="25400" rIns="25400" tIns="0" bIns="0"/>
+          <a:lstStyle/>
+          <a:p>
+            <a:pPr algn="ctr"/>
+            <a:r>
+              <a:rPr sz="850" b="1">
+                <a:solidFill>
+                  <a:srgbClr val="2E7D46"/>
+                </a:solidFill>
+                <a:latin typeface="Calibri"/>
+              </a:rPr>
+              <a:t>Must</a:t>
+            </a:r>
+          </a:p>
+        </p:txBody>
+      </p:sp>
+      <p:sp>
+        <p:nvSpPr>
+          <p:cNvPr id="80" name="TextBox 79"/>
+          <p:cNvSpPr txBox="1"/>
+          <p:nvPr/>
+        </p:nvSpPr>
+        <p:spPr>
+          <a:xfrm>
+            <a:off x="1238504" y="4736592"/>
+            <a:ext cx="2696407" cy="327355"/>
+          </a:xfrm>
+          <a:prstGeom prst="rect">
+            <a:avLst/>
+          </a:prstGeom>
+          <a:noFill/>
+        </p:spPr>
+        <p:txBody>
+          <a:bodyPr wrap="square" anchor="ctr" lIns="0" rIns="0" tIns="0" bIns="0">
+            <a:spAutoFit/>
+          </a:bodyPr>
+          <a:lstStyle/>
+          <a:p>
+            <a:pPr algn="l">
+              <a:lnSpc>
+                <a:spcPct val="100000"/>
+              </a:lnSpc>
+              <a:spcBef>
+                <a:spcPts val="0"/>
+              </a:spcBef>
+              <a:spcAft>
+                <a:spcPts val="200"/>
+              </a:spcAft>
+            </a:pPr>
+            <a:r>
+              <a:rPr sz="930" b="1">
+                <a:solidFill>
+                  <a:srgbClr val="1A2733"/>
+                </a:solidFill>
+                <a:latin typeface="Calibri"/>
+              </a:rPr>
+              <a:t>Safe degraded (NEA / ML / LLM) mode</a:t>
+            </a:r>
+          </a:p>
+        </p:txBody>
+      </p:sp>
+      <p:sp>
+        <p:nvSpPr>
+          <p:cNvPr id="81" name="TextBox 80"/>
+          <p:cNvSpPr txBox="1"/>
+          <p:nvPr/>
+        </p:nvSpPr>
+        <p:spPr>
+          <a:xfrm>
+            <a:off x="4044639" y="4736592"/>
+            <a:ext cx="2908017" cy="327355"/>
+          </a:xfrm>
+          <a:prstGeom prst="rect">
+            <a:avLst/>
+          </a:prstGeom>
+          <a:noFill/>
+        </p:spPr>
+        <p:txBody>
+          <a:bodyPr wrap="square" anchor="ctr" lIns="0" rIns="0" tIns="0" bIns="0">
+            <a:spAutoFit/>
+          </a:bodyPr>
+          <a:lstStyle/>
+          <a:p>
+            <a:pPr algn="l">
+              <a:lnSpc>
+                <a:spcPct val="100000"/>
+              </a:lnSpc>
+              <a:spcBef>
+                <a:spcPts val="0"/>
+              </a:spcBef>
+              <a:spcAft>
+                <a:spcPts val="200"/>
+              </a:spcAft>
+            </a:pPr>
+            <a:r>
+              <a:rPr sz="930" b="0">
+                <a:solidFill>
+                  <a:srgbClr val="6B7A88"/>
+                </a:solidFill>
+                <a:latin typeface="Calibri"/>
+              </a:rPr>
+              <a:t>Fallback adapters · persistence forecast</a:t>
+            </a:r>
+          </a:p>
+        </p:txBody>
+      </p:sp>
+      <p:sp>
+        <p:nvSpPr>
+          <p:cNvPr id="82" name="TextBox 81"/>
+          <p:cNvSpPr txBox="1"/>
+          <p:nvPr/>
+        </p:nvSpPr>
+        <p:spPr>
+          <a:xfrm>
+            <a:off x="6989233" y="4736592"/>
+            <a:ext cx="460022" cy="327355"/>
+          </a:xfrm>
+          <a:prstGeom prst="rect">
+            <a:avLst/>
+          </a:prstGeom>
+          <a:noFill/>
+        </p:spPr>
+        <p:txBody>
+          <a:bodyPr wrap="square" anchor="ctr" lIns="0" rIns="0" tIns="0" bIns="0">
+            <a:spAutoFit/>
+          </a:bodyPr>
+          <a:lstStyle/>
+          <a:p>
+            <a:pPr algn="ctr">
+              <a:lnSpc>
+                <a:spcPct val="100000"/>
+              </a:lnSpc>
+              <a:spcBef>
+                <a:spcPts val="0"/>
+              </a:spcBef>
+              <a:spcAft>
+                <a:spcPts val="200"/>
+              </a:spcAft>
+            </a:pPr>
+            <a:r>
+              <a:rPr sz="950" b="0">
+                <a:solidFill>
+                  <a:srgbClr val="1A2733"/>
+                </a:solidFill>
+                <a:latin typeface="Calibri"/>
+              </a:rPr>
+              <a:t>8</a:t>
+            </a:r>
+          </a:p>
+        </p:txBody>
+      </p:sp>
+      <p:sp>
+        <p:nvSpPr>
+          <p:cNvPr id="83" name="TextBox 82"/>
+          <p:cNvSpPr txBox="1"/>
+          <p:nvPr/>
+        </p:nvSpPr>
+        <p:spPr>
+          <a:xfrm>
+            <a:off x="7449255" y="4736592"/>
+            <a:ext cx="506024" cy="327355"/>
+          </a:xfrm>
+          <a:prstGeom prst="rect">
+            <a:avLst/>
+          </a:prstGeom>
+          <a:noFill/>
+        </p:spPr>
+        <p:txBody>
+          <a:bodyPr wrap="square" anchor="ctr" lIns="0" rIns="0" tIns="0" bIns="0">
+            <a:spAutoFit/>
+          </a:bodyPr>
+          <a:lstStyle/>
+          <a:p>
+            <a:pPr algn="ctr">
+              <a:lnSpc>
+                <a:spcPct val="100000"/>
+              </a:lnSpc>
+              <a:spcBef>
+                <a:spcPts val="0"/>
+              </a:spcBef>
+              <a:spcAft>
+                <a:spcPts val="200"/>
+              </a:spcAft>
+            </a:pPr>
+            <a:r>
+              <a:rPr sz="950" b="0">
+                <a:solidFill>
+                  <a:srgbClr val="1A2733"/>
+                </a:solidFill>
+                <a:latin typeface="Calibri"/>
+              </a:rPr>
+              <a:t>3</a:t>
+            </a:r>
+          </a:p>
+        </p:txBody>
+      </p:sp>
+      <p:sp>
+        <p:nvSpPr>
+          <p:cNvPr id="84" name="Rectangle 83"/>
+          <p:cNvSpPr/>
+          <p:nvPr/>
+        </p:nvSpPr>
+        <p:spPr>
+          <a:xfrm>
+            <a:off x="502920" y="5058460"/>
+            <a:ext cx="7452360" cy="5486"/>
+          </a:xfrm>
+          <a:prstGeom prst="rect">
+            <a:avLst/>
+          </a:prstGeom>
+          <a:solidFill>
+            <a:srgbClr val="E1E8EF"/>
+          </a:solidFill>
+          <a:ln>
+            <a:noFill/>
+          </a:ln>
+          <a:effectLst/>
+        </p:spPr>
+        <p:style>
+          <a:lnRef idx="1">
+            <a:schemeClr val="accent1"/>
+          </a:lnRef>
+          <a:fillRef idx="3">
+            <a:schemeClr val="accent1"/>
+          </a:fillRef>
+          <a:effectRef idx="2">
+            <a:schemeClr val="accent1"/>
+          </a:effectRef>
+          <a:fontRef idx="minor">
+            <a:schemeClr val="lt1"/>
+          </a:fontRef>
+        </p:style>
+        <p:txBody>
+          <a:bodyPr rtlCol="0" anchor="ctr"/>
+          <a:lstStyle/>
+          <a:p>
+            <a:pPr algn="ctr"/>
+          </a:p>
+        </p:txBody>
+      </p:sp>
+      <p:sp>
+        <p:nvSpPr>
+          <p:cNvPr id="85" name="Rounded Rectangle 84"/>
+          <p:cNvSpPr/>
+          <p:nvPr/>
+        </p:nvSpPr>
+        <p:spPr>
+          <a:xfrm>
+            <a:off x="502920" y="5191963"/>
             <a:ext cx="7452360" cy="676656"/>
           </a:xfrm>
           <a:prstGeom prst="roundRect">
@@ -7765,13 +8088,13 @@
       </p:sp>
       <p:sp>
         <p:nvSpPr>
-          <p:cNvPr id="79" name="TextBox 78"/>
+          <p:cNvPr id="86" name="TextBox 85"/>
           <p:cNvSpPr txBox="1"/>
           <p:nvPr/>
         </p:nvSpPr>
         <p:spPr>
           <a:xfrm>
-            <a:off x="667512" y="4956047"/>
+            <a:off x="667512" y="5283403"/>
             <a:ext cx="7141464" cy="548640"/>
           </a:xfrm>
           <a:prstGeom prst="rect">
@@ -7812,7 +8135,7 @@
                 </a:solidFill>
                 <a:latin typeface="Calibri"/>
               </a:rPr>
-              <a:t>Cloud — Azure Container Apps · Static Web Apps · Azure PostgreSQL · Blob Storage</a:t>
+              <a:t>Cloud — AWS Amplify Hosting (S3 + CloudFront) · ECS on Fargate · RDS for PostgreSQL · S3 · Secrets Manager</a:t>
             </a:r>
           </a:p>
           <a:p>
@@ -7850,7 +8173,7 @@
       </p:sp>
       <p:sp>
         <p:nvSpPr>
-          <p:cNvPr id="80" name="TextBox 79"/>
+          <p:cNvPr id="87" name="TextBox 86"/>
           <p:cNvSpPr txBox="1"/>
           <p:nvPr/>
         </p:nvSpPr>
@@ -7895,7 +8218,7 @@
       </p:sp>
       <p:sp>
         <p:nvSpPr>
-          <p:cNvPr id="81" name="Rectangle 80"/>
+          <p:cNvPr id="88" name="Rectangle 87"/>
           <p:cNvSpPr/>
           <p:nvPr/>
         </p:nvSpPr>
@@ -7941,7 +8264,7 @@
       </p:sp>
       <p:pic>
         <p:nvPicPr>
-          <p:cNvPr id="82" name="Picture 81" descr="m1.png"/>
+          <p:cNvPr id="89" name="Picture 88" descr="m1.png"/>
           <p:cNvPicPr>
             <a:picLocks noChangeAspect="1"/>
           </p:cNvPicPr>
@@ -7965,7 +8288,7 @@
       </p:pic>
       <p:sp>
         <p:nvSpPr>
-          <p:cNvPr id="83" name="TextBox 82"/>
+          <p:cNvPr id="90" name="TextBox 89"/>
           <p:cNvSpPr txBox="1"/>
           <p:nvPr/>
         </p:nvSpPr>
@@ -8010,7 +8333,7 @@
       </p:sp>
       <p:sp>
         <p:nvSpPr>
-          <p:cNvPr id="84" name="Rectangle 83"/>
+          <p:cNvPr id="91" name="Rectangle 90"/>
           <p:cNvSpPr/>
           <p:nvPr/>
         </p:nvSpPr>
@@ -8056,7 +8379,7 @@
       </p:sp>
       <p:pic>
         <p:nvPicPr>
-          <p:cNvPr id="85" name="Picture 84" descr="m2.png"/>
+          <p:cNvPr id="92" name="Picture 91" descr="m2.png"/>
           <p:cNvPicPr>
             <a:picLocks noChangeAspect="1"/>
           </p:cNvPicPr>
@@ -8080,7 +8403,7 @@
       </p:pic>
       <p:sp>
         <p:nvSpPr>
-          <p:cNvPr id="86" name="TextBox 85"/>
+          <p:cNvPr id="93" name="TextBox 92"/>
           <p:cNvSpPr txBox="1"/>
           <p:nvPr/>
         </p:nvSpPr>
@@ -8125,7 +8448,7 @@
       </p:sp>
       <p:sp>
         <p:nvSpPr>
-          <p:cNvPr id="87" name="Rectangle 86"/>
+          <p:cNvPr id="94" name="Rectangle 93"/>
           <p:cNvSpPr/>
           <p:nvPr/>
         </p:nvSpPr>
@@ -8171,7 +8494,7 @@
       </p:sp>
       <p:pic>
         <p:nvPicPr>
-          <p:cNvPr id="88" name="Picture 87" descr="w1.png"/>
+          <p:cNvPr id="95" name="Picture 94" descr="w1.png"/>
           <p:cNvPicPr>
             <a:picLocks noChangeAspect="1"/>
           </p:cNvPicPr>
@@ -8195,7 +8518,7 @@
       </p:pic>
       <p:sp>
         <p:nvSpPr>
-          <p:cNvPr id="89" name="TextBox 88"/>
+          <p:cNvPr id="96" name="TextBox 95"/>
           <p:cNvSpPr txBox="1"/>
           <p:nvPr/>
         </p:nvSpPr>
@@ -8240,7 +8563,7 @@
       </p:sp>
       <p:sp>
         <p:nvSpPr>
-          <p:cNvPr id="90" name="Rectangle 89"/>
+          <p:cNvPr id="97" name="Rectangle 96"/>
           <p:cNvSpPr/>
           <p:nvPr/>
         </p:nvSpPr>
@@ -8286,7 +8609,7 @@
       </p:sp>
       <p:pic>
         <p:nvPicPr>
-          <p:cNvPr id="91" name="Picture 90" descr="w2.png"/>
+          <p:cNvPr id="98" name="Picture 97" descr="w2.png"/>
           <p:cNvPicPr>
             <a:picLocks noChangeAspect="1"/>
           </p:cNvPicPr>
@@ -8310,7 +8633,7 @@
       </p:pic>
       <p:sp>
         <p:nvSpPr>
-          <p:cNvPr id="92" name="TextBox 91"/>
+          <p:cNvPr id="99" name="TextBox 98"/>
           <p:cNvSpPr txBox="1"/>
           <p:nvPr/>
         </p:nvSpPr>

</xml_diff>

<commit_message>
Change aws amplify to terraform
</commit_message>
<xml_diff>
--- a/proposal-deliverables/WBGT-CrewSafe-SG-Proposal.pptx
+++ b/proposal-deliverables/WBGT-CrewSafe-SG-Proposal.pptx
@@ -5,10 +5,10 @@
     <p:sldMasterId id="2147483648" r:id="rId1"/>
   </p:sldMasterIdLst>
   <p:sldIdLst>
-    <p:sldId id="256" r:id="rId7"/>
-    <p:sldId id="257" r:id="rId8"/>
+    <p:sldId id="256" r:id="rId2"/>
+    <p:sldId id="257" r:id="rId3"/>
   </p:sldIdLst>
-  <p:sldSz cx="12191695" cy="6858000" type="screen4x3"/>
+  <p:sldSz cx="12192000" cy="6858000"/>
   <p:notesSz cx="6858000" cy="9144000"/>
   <p:defaultTextStyle>
     <a:defPPr>
@@ -105,6 +105,22 @@
       </a:defRPr>
     </a:lvl9pPr>
   </p:defaultTextStyle>
+  <p:extLst>
+    <p:ext uri="{EFAFB233-063F-42B5-8137-9DF3F51BA10A}">
+      <p15:sldGuideLst xmlns:p15="http://schemas.microsoft.com/office/powerpoint/2012/main">
+        <p15:guide id="1" orient="horz" pos="2160">
+          <p15:clr>
+            <a:srgbClr val="A4A3A4"/>
+          </p15:clr>
+        </p15:guide>
+        <p15:guide id="2" pos="2880">
+          <p15:clr>
+            <a:srgbClr val="A4A3A4"/>
+          </p15:clr>
+        </p15:guide>
+      </p15:sldGuideLst>
+    </p:ext>
+  </p:extLst>
 </p:presentation>
 </file>
 
@@ -146,10 +162,9 @@
           <a:lstStyle/>
           <a:p>
             <a:r>
-              <a:rPr lang="en-US" smtClean="0"/>
+              <a:rPr lang="en-US"/>
               <a:t>Click to edit Master title style</a:t>
             </a:r>
-            <a:endParaRPr lang="en-US"/>
           </a:p>
         </p:txBody>
       </p:sp>
@@ -265,10 +280,9 @@
           </a:lstStyle>
           <a:p>
             <a:r>
-              <a:rPr lang="en-US" smtClean="0"/>
+              <a:rPr lang="en-US"/>
               <a:t>Click to edit Master subtitle style</a:t>
             </a:r>
-            <a:endParaRPr lang="en-US"/>
           </a:p>
         </p:txBody>
       </p:sp>
@@ -289,7 +303,7 @@
           <a:p>
             <a:fld id="{5BCAD085-E8A6-8845-BD4E-CB4CCA059FC4}" type="datetimeFigureOut">
               <a:rPr lang="en-US" smtClean="0"/>
-              <a:t>1/27/13</a:t>
+              <a:t>7/25/26</a:t>
             </a:fld>
             <a:endParaRPr lang="en-US"/>
           </a:p>
@@ -383,10 +397,9 @@
           <a:lstStyle/>
           <a:p>
             <a:r>
-              <a:rPr lang="en-US" smtClean="0"/>
+              <a:rPr lang="en-US"/>
               <a:t>Click to edit Master title style</a:t>
             </a:r>
-            <a:endParaRPr lang="en-US"/>
           </a:p>
         </p:txBody>
       </p:sp>
@@ -407,38 +420,37 @@
           <a:p>
             <a:pPr lvl="0"/>
             <a:r>
-              <a:rPr lang="en-US" smtClean="0"/>
+              <a:rPr lang="en-US"/>
               <a:t>Click to edit Master text styles</a:t>
             </a:r>
           </a:p>
           <a:p>
             <a:pPr lvl="1"/>
             <a:r>
-              <a:rPr lang="en-US" smtClean="0"/>
+              <a:rPr lang="en-US"/>
               <a:t>Second level</a:t>
             </a:r>
           </a:p>
           <a:p>
             <a:pPr lvl="2"/>
             <a:r>
-              <a:rPr lang="en-US" smtClean="0"/>
+              <a:rPr lang="en-US"/>
               <a:t>Third level</a:t>
             </a:r>
           </a:p>
           <a:p>
             <a:pPr lvl="3"/>
             <a:r>
-              <a:rPr lang="en-US" smtClean="0"/>
+              <a:rPr lang="en-US"/>
               <a:t>Fourth level</a:t>
             </a:r>
           </a:p>
           <a:p>
             <a:pPr lvl="4"/>
             <a:r>
-              <a:rPr lang="en-US" smtClean="0"/>
+              <a:rPr lang="en-US"/>
               <a:t>Fifth level</a:t>
             </a:r>
-            <a:endParaRPr lang="en-US"/>
           </a:p>
         </p:txBody>
       </p:sp>
@@ -459,7 +471,7 @@
           <a:p>
             <a:fld id="{5BCAD085-E8A6-8845-BD4E-CB4CCA059FC4}" type="datetimeFigureOut">
               <a:rPr lang="en-US" smtClean="0"/>
-              <a:t>1/27/13</a:t>
+              <a:t>7/25/26</a:t>
             </a:fld>
             <a:endParaRPr lang="en-US"/>
           </a:p>
@@ -558,10 +570,9 @@
           <a:lstStyle/>
           <a:p>
             <a:r>
-              <a:rPr lang="en-US" smtClean="0"/>
+              <a:rPr lang="en-US"/>
               <a:t>Click to edit Master title style</a:t>
             </a:r>
-            <a:endParaRPr lang="en-US"/>
           </a:p>
         </p:txBody>
       </p:sp>
@@ -587,38 +598,37 @@
           <a:p>
             <a:pPr lvl="0"/>
             <a:r>
-              <a:rPr lang="en-US" smtClean="0"/>
+              <a:rPr lang="en-US"/>
               <a:t>Click to edit Master text styles</a:t>
             </a:r>
           </a:p>
           <a:p>
             <a:pPr lvl="1"/>
             <a:r>
-              <a:rPr lang="en-US" smtClean="0"/>
+              <a:rPr lang="en-US"/>
               <a:t>Second level</a:t>
             </a:r>
           </a:p>
           <a:p>
             <a:pPr lvl="2"/>
             <a:r>
-              <a:rPr lang="en-US" smtClean="0"/>
+              <a:rPr lang="en-US"/>
               <a:t>Third level</a:t>
             </a:r>
           </a:p>
           <a:p>
             <a:pPr lvl="3"/>
             <a:r>
-              <a:rPr lang="en-US" smtClean="0"/>
+              <a:rPr lang="en-US"/>
               <a:t>Fourth level</a:t>
             </a:r>
           </a:p>
           <a:p>
             <a:pPr lvl="4"/>
             <a:r>
-              <a:rPr lang="en-US" smtClean="0"/>
+              <a:rPr lang="en-US"/>
               <a:t>Fifth level</a:t>
             </a:r>
-            <a:endParaRPr lang="en-US"/>
           </a:p>
         </p:txBody>
       </p:sp>
@@ -639,7 +649,7 @@
           <a:p>
             <a:fld id="{5BCAD085-E8A6-8845-BD4E-CB4CCA059FC4}" type="datetimeFigureOut">
               <a:rPr lang="en-US" smtClean="0"/>
-              <a:t>1/27/13</a:t>
+              <a:t>7/25/26</a:t>
             </a:fld>
             <a:endParaRPr lang="en-US"/>
           </a:p>
@@ -733,10 +743,9 @@
           <a:lstStyle/>
           <a:p>
             <a:r>
-              <a:rPr lang="en-US" smtClean="0"/>
+              <a:rPr lang="en-US"/>
               <a:t>Click to edit Master title style</a:t>
             </a:r>
-            <a:endParaRPr lang="en-US"/>
           </a:p>
         </p:txBody>
       </p:sp>
@@ -757,38 +766,37 @@
           <a:p>
             <a:pPr lvl="0"/>
             <a:r>
-              <a:rPr lang="en-US" smtClean="0"/>
+              <a:rPr lang="en-US"/>
               <a:t>Click to edit Master text styles</a:t>
             </a:r>
           </a:p>
           <a:p>
             <a:pPr lvl="1"/>
             <a:r>
-              <a:rPr lang="en-US" smtClean="0"/>
+              <a:rPr lang="en-US"/>
               <a:t>Second level</a:t>
             </a:r>
           </a:p>
           <a:p>
             <a:pPr lvl="2"/>
             <a:r>
-              <a:rPr lang="en-US" smtClean="0"/>
+              <a:rPr lang="en-US"/>
               <a:t>Third level</a:t>
             </a:r>
           </a:p>
           <a:p>
             <a:pPr lvl="3"/>
             <a:r>
-              <a:rPr lang="en-US" smtClean="0"/>
+              <a:rPr lang="en-US"/>
               <a:t>Fourth level</a:t>
             </a:r>
           </a:p>
           <a:p>
             <a:pPr lvl="4"/>
             <a:r>
-              <a:rPr lang="en-US" smtClean="0"/>
+              <a:rPr lang="en-US"/>
               <a:t>Fifth level</a:t>
             </a:r>
-            <a:endParaRPr lang="en-US"/>
           </a:p>
         </p:txBody>
       </p:sp>
@@ -809,7 +817,7 @@
           <a:p>
             <a:fld id="{5BCAD085-E8A6-8845-BD4E-CB4CCA059FC4}" type="datetimeFigureOut">
               <a:rPr lang="en-US" smtClean="0"/>
-              <a:t>1/27/13</a:t>
+              <a:t>7/25/26</a:t>
             </a:fld>
             <a:endParaRPr lang="en-US"/>
           </a:p>
@@ -912,10 +920,9 @@
           </a:lstStyle>
           <a:p>
             <a:r>
-              <a:rPr lang="en-US" smtClean="0"/>
+              <a:rPr lang="en-US"/>
               <a:t>Click to edit Master title style</a:t>
             </a:r>
-            <a:endParaRPr lang="en-US"/>
           </a:p>
         </p:txBody>
       </p:sp>
@@ -1032,7 +1039,7 @@
           <a:p>
             <a:pPr lvl="0"/>
             <a:r>
-              <a:rPr lang="en-US" smtClean="0"/>
+              <a:rPr lang="en-US"/>
               <a:t>Click to edit Master text styles</a:t>
             </a:r>
           </a:p>
@@ -1055,7 +1062,7 @@
           <a:p>
             <a:fld id="{5BCAD085-E8A6-8845-BD4E-CB4CCA059FC4}" type="datetimeFigureOut">
               <a:rPr lang="en-US" smtClean="0"/>
-              <a:t>1/27/13</a:t>
+              <a:t>7/25/26</a:t>
             </a:fld>
             <a:endParaRPr lang="en-US"/>
           </a:p>
@@ -1149,10 +1156,9 @@
           <a:lstStyle/>
           <a:p>
             <a:r>
-              <a:rPr lang="en-US" smtClean="0"/>
+              <a:rPr lang="en-US"/>
               <a:t>Click to edit Master title style</a:t>
             </a:r>
-            <a:endParaRPr lang="en-US"/>
           </a:p>
         </p:txBody>
       </p:sp>
@@ -1206,38 +1212,37 @@
           <a:p>
             <a:pPr lvl="0"/>
             <a:r>
-              <a:rPr lang="en-US" smtClean="0"/>
+              <a:rPr lang="en-US"/>
               <a:t>Click to edit Master text styles</a:t>
             </a:r>
           </a:p>
           <a:p>
             <a:pPr lvl="1"/>
             <a:r>
-              <a:rPr lang="en-US" smtClean="0"/>
+              <a:rPr lang="en-US"/>
               <a:t>Second level</a:t>
             </a:r>
           </a:p>
           <a:p>
             <a:pPr lvl="2"/>
             <a:r>
-              <a:rPr lang="en-US" smtClean="0"/>
+              <a:rPr lang="en-US"/>
               <a:t>Third level</a:t>
             </a:r>
           </a:p>
           <a:p>
             <a:pPr lvl="3"/>
             <a:r>
-              <a:rPr lang="en-US" smtClean="0"/>
+              <a:rPr lang="en-US"/>
               <a:t>Fourth level</a:t>
             </a:r>
           </a:p>
           <a:p>
             <a:pPr lvl="4"/>
             <a:r>
-              <a:rPr lang="en-US" smtClean="0"/>
+              <a:rPr lang="en-US"/>
               <a:t>Fifth level</a:t>
             </a:r>
-            <a:endParaRPr lang="en-US"/>
           </a:p>
         </p:txBody>
       </p:sp>
@@ -1291,38 +1296,37 @@
           <a:p>
             <a:pPr lvl="0"/>
             <a:r>
-              <a:rPr lang="en-US" smtClean="0"/>
+              <a:rPr lang="en-US"/>
               <a:t>Click to edit Master text styles</a:t>
             </a:r>
           </a:p>
           <a:p>
             <a:pPr lvl="1"/>
             <a:r>
-              <a:rPr lang="en-US" smtClean="0"/>
+              <a:rPr lang="en-US"/>
               <a:t>Second level</a:t>
             </a:r>
           </a:p>
           <a:p>
             <a:pPr lvl="2"/>
             <a:r>
-              <a:rPr lang="en-US" smtClean="0"/>
+              <a:rPr lang="en-US"/>
               <a:t>Third level</a:t>
             </a:r>
           </a:p>
           <a:p>
             <a:pPr lvl="3"/>
             <a:r>
-              <a:rPr lang="en-US" smtClean="0"/>
+              <a:rPr lang="en-US"/>
               <a:t>Fourth level</a:t>
             </a:r>
           </a:p>
           <a:p>
             <a:pPr lvl="4"/>
             <a:r>
-              <a:rPr lang="en-US" smtClean="0"/>
+              <a:rPr lang="en-US"/>
               <a:t>Fifth level</a:t>
             </a:r>
-            <a:endParaRPr lang="en-US"/>
           </a:p>
         </p:txBody>
       </p:sp>
@@ -1343,7 +1347,7 @@
           <a:p>
             <a:fld id="{5BCAD085-E8A6-8845-BD4E-CB4CCA059FC4}" type="datetimeFigureOut">
               <a:rPr lang="en-US" smtClean="0"/>
-              <a:t>1/27/13</a:t>
+              <a:t>7/25/26</a:t>
             </a:fld>
             <a:endParaRPr lang="en-US"/>
           </a:p>
@@ -1441,10 +1445,9 @@
           </a:lstStyle>
           <a:p>
             <a:r>
-              <a:rPr lang="en-US" smtClean="0"/>
+              <a:rPr lang="en-US"/>
               <a:t>Click to edit Master title style</a:t>
             </a:r>
-            <a:endParaRPr lang="en-US"/>
           </a:p>
         </p:txBody>
       </p:sp>
@@ -1507,7 +1510,7 @@
           <a:p>
             <a:pPr lvl="0"/>
             <a:r>
-              <a:rPr lang="en-US" smtClean="0"/>
+              <a:rPr lang="en-US"/>
               <a:t>Click to edit Master text styles</a:t>
             </a:r>
           </a:p>
@@ -1563,38 +1566,37 @@
           <a:p>
             <a:pPr lvl="0"/>
             <a:r>
-              <a:rPr lang="en-US" smtClean="0"/>
+              <a:rPr lang="en-US"/>
               <a:t>Click to edit Master text styles</a:t>
             </a:r>
           </a:p>
           <a:p>
             <a:pPr lvl="1"/>
             <a:r>
-              <a:rPr lang="en-US" smtClean="0"/>
+              <a:rPr lang="en-US"/>
               <a:t>Second level</a:t>
             </a:r>
           </a:p>
           <a:p>
             <a:pPr lvl="2"/>
             <a:r>
-              <a:rPr lang="en-US" smtClean="0"/>
+              <a:rPr lang="en-US"/>
               <a:t>Third level</a:t>
             </a:r>
           </a:p>
           <a:p>
             <a:pPr lvl="3"/>
             <a:r>
-              <a:rPr lang="en-US" smtClean="0"/>
+              <a:rPr lang="en-US"/>
               <a:t>Fourth level</a:t>
             </a:r>
           </a:p>
           <a:p>
             <a:pPr lvl="4"/>
             <a:r>
-              <a:rPr lang="en-US" smtClean="0"/>
+              <a:rPr lang="en-US"/>
               <a:t>Fifth level</a:t>
             </a:r>
-            <a:endParaRPr lang="en-US"/>
           </a:p>
         </p:txBody>
       </p:sp>
@@ -1657,7 +1659,7 @@
           <a:p>
             <a:pPr lvl="0"/>
             <a:r>
-              <a:rPr lang="en-US" smtClean="0"/>
+              <a:rPr lang="en-US"/>
               <a:t>Click to edit Master text styles</a:t>
             </a:r>
           </a:p>
@@ -1713,38 +1715,37 @@
           <a:p>
             <a:pPr lvl="0"/>
             <a:r>
-              <a:rPr lang="en-US" smtClean="0"/>
+              <a:rPr lang="en-US"/>
               <a:t>Click to edit Master text styles</a:t>
             </a:r>
           </a:p>
           <a:p>
             <a:pPr lvl="1"/>
             <a:r>
-              <a:rPr lang="en-US" smtClean="0"/>
+              <a:rPr lang="en-US"/>
               <a:t>Second level</a:t>
             </a:r>
           </a:p>
           <a:p>
             <a:pPr lvl="2"/>
             <a:r>
-              <a:rPr lang="en-US" smtClean="0"/>
+              <a:rPr lang="en-US"/>
               <a:t>Third level</a:t>
             </a:r>
           </a:p>
           <a:p>
             <a:pPr lvl="3"/>
             <a:r>
-              <a:rPr lang="en-US" smtClean="0"/>
+              <a:rPr lang="en-US"/>
               <a:t>Fourth level</a:t>
             </a:r>
           </a:p>
           <a:p>
             <a:pPr lvl="4"/>
             <a:r>
-              <a:rPr lang="en-US" smtClean="0"/>
+              <a:rPr lang="en-US"/>
               <a:t>Fifth level</a:t>
             </a:r>
-            <a:endParaRPr lang="en-US"/>
           </a:p>
         </p:txBody>
       </p:sp>
@@ -1765,7 +1766,7 @@
           <a:p>
             <a:fld id="{5BCAD085-E8A6-8845-BD4E-CB4CCA059FC4}" type="datetimeFigureOut">
               <a:rPr lang="en-US" smtClean="0"/>
-              <a:t>1/27/13</a:t>
+              <a:t>7/25/26</a:t>
             </a:fld>
             <a:endParaRPr lang="en-US"/>
           </a:p>
@@ -1859,10 +1860,9 @@
           <a:lstStyle/>
           <a:p>
             <a:r>
-              <a:rPr lang="en-US" smtClean="0"/>
+              <a:rPr lang="en-US"/>
               <a:t>Click to edit Master title style</a:t>
             </a:r>
-            <a:endParaRPr lang="en-US"/>
           </a:p>
         </p:txBody>
       </p:sp>
@@ -1883,7 +1883,7 @@
           <a:p>
             <a:fld id="{5BCAD085-E8A6-8845-BD4E-CB4CCA059FC4}" type="datetimeFigureOut">
               <a:rPr lang="en-US" smtClean="0"/>
-              <a:t>1/27/13</a:t>
+              <a:t>7/25/26</a:t>
             </a:fld>
             <a:endParaRPr lang="en-US"/>
           </a:p>
@@ -1978,7 +1978,7 @@
           <a:p>
             <a:fld id="{5BCAD085-E8A6-8845-BD4E-CB4CCA059FC4}" type="datetimeFigureOut">
               <a:rPr lang="en-US" smtClean="0"/>
-              <a:t>1/27/13</a:t>
+              <a:t>7/25/26</a:t>
             </a:fld>
             <a:endParaRPr lang="en-US"/>
           </a:p>
@@ -2081,10 +2081,9 @@
           </a:lstStyle>
           <a:p>
             <a:r>
-              <a:rPr lang="en-US" smtClean="0"/>
+              <a:rPr lang="en-US"/>
               <a:t>Click to edit Master title style</a:t>
             </a:r>
-            <a:endParaRPr lang="en-US"/>
           </a:p>
         </p:txBody>
       </p:sp>
@@ -2138,38 +2137,37 @@
           <a:p>
             <a:pPr lvl="0"/>
             <a:r>
-              <a:rPr lang="en-US" smtClean="0"/>
+              <a:rPr lang="en-US"/>
               <a:t>Click to edit Master text styles</a:t>
             </a:r>
           </a:p>
           <a:p>
             <a:pPr lvl="1"/>
             <a:r>
-              <a:rPr lang="en-US" smtClean="0"/>
+              <a:rPr lang="en-US"/>
               <a:t>Second level</a:t>
             </a:r>
           </a:p>
           <a:p>
             <a:pPr lvl="2"/>
             <a:r>
-              <a:rPr lang="en-US" smtClean="0"/>
+              <a:rPr lang="en-US"/>
               <a:t>Third level</a:t>
             </a:r>
           </a:p>
           <a:p>
             <a:pPr lvl="3"/>
             <a:r>
-              <a:rPr lang="en-US" smtClean="0"/>
+              <a:rPr lang="en-US"/>
               <a:t>Fourth level</a:t>
             </a:r>
           </a:p>
           <a:p>
             <a:pPr lvl="4"/>
             <a:r>
-              <a:rPr lang="en-US" smtClean="0"/>
+              <a:rPr lang="en-US"/>
               <a:t>Fifth level</a:t>
             </a:r>
-            <a:endParaRPr lang="en-US"/>
           </a:p>
         </p:txBody>
       </p:sp>
@@ -2232,7 +2230,7 @@
           <a:p>
             <a:pPr lvl="0"/>
             <a:r>
-              <a:rPr lang="en-US" smtClean="0"/>
+              <a:rPr lang="en-US"/>
               <a:t>Click to edit Master text styles</a:t>
             </a:r>
           </a:p>
@@ -2255,7 +2253,7 @@
           <a:p>
             <a:fld id="{5BCAD085-E8A6-8845-BD4E-CB4CCA059FC4}" type="datetimeFigureOut">
               <a:rPr lang="en-US" smtClean="0"/>
-              <a:t>1/27/13</a:t>
+              <a:t>7/25/26</a:t>
             </a:fld>
             <a:endParaRPr lang="en-US"/>
           </a:p>
@@ -2358,10 +2356,9 @@
           </a:lstStyle>
           <a:p>
             <a:r>
-              <a:rPr lang="en-US" smtClean="0"/>
+              <a:rPr lang="en-US"/>
               <a:t>Click to edit Master title style</a:t>
             </a:r>
-            <a:endParaRPr lang="en-US"/>
           </a:p>
         </p:txBody>
       </p:sp>
@@ -2485,7 +2482,7 @@
           <a:p>
             <a:pPr lvl="0"/>
             <a:r>
-              <a:rPr lang="en-US" smtClean="0"/>
+              <a:rPr lang="en-US"/>
               <a:t>Click to edit Master text styles</a:t>
             </a:r>
           </a:p>
@@ -2508,7 +2505,7 @@
           <a:p>
             <a:fld id="{5BCAD085-E8A6-8845-BD4E-CB4CCA059FC4}" type="datetimeFigureOut">
               <a:rPr lang="en-US" smtClean="0"/>
-              <a:t>1/27/13</a:t>
+              <a:t>7/25/26</a:t>
             </a:fld>
             <a:endParaRPr lang="en-US"/>
           </a:p>
@@ -2617,10 +2614,9 @@
           <a:lstStyle/>
           <a:p>
             <a:r>
-              <a:rPr lang="en-US" smtClean="0"/>
+              <a:rPr lang="en-US"/>
               <a:t>Click to edit Master title style</a:t>
             </a:r>
-            <a:endParaRPr lang="en-US"/>
           </a:p>
         </p:txBody>
       </p:sp>
@@ -2651,38 +2647,37 @@
           <a:p>
             <a:pPr lvl="0"/>
             <a:r>
-              <a:rPr lang="en-US" smtClean="0"/>
+              <a:rPr lang="en-US"/>
               <a:t>Click to edit Master text styles</a:t>
             </a:r>
           </a:p>
           <a:p>
             <a:pPr lvl="1"/>
             <a:r>
-              <a:rPr lang="en-US" smtClean="0"/>
+              <a:rPr lang="en-US"/>
               <a:t>Second level</a:t>
             </a:r>
           </a:p>
           <a:p>
             <a:pPr lvl="2"/>
             <a:r>
-              <a:rPr lang="en-US" smtClean="0"/>
+              <a:rPr lang="en-US"/>
               <a:t>Third level</a:t>
             </a:r>
           </a:p>
           <a:p>
             <a:pPr lvl="3"/>
             <a:r>
-              <a:rPr lang="en-US" smtClean="0"/>
+              <a:rPr lang="en-US"/>
               <a:t>Fourth level</a:t>
             </a:r>
           </a:p>
           <a:p>
             <a:pPr lvl="4"/>
             <a:r>
-              <a:rPr lang="en-US" smtClean="0"/>
+              <a:rPr lang="en-US"/>
               <a:t>Fifth level</a:t>
             </a:r>
-            <a:endParaRPr lang="en-US"/>
           </a:p>
         </p:txBody>
       </p:sp>
@@ -2721,7 +2716,7 @@
           <a:p>
             <a:fld id="{5BCAD085-E8A6-8845-BD4E-CB4CCA059FC4}" type="datetimeFigureOut">
               <a:rPr lang="en-US" smtClean="0"/>
-              <a:t>1/27/13</a:t>
+              <a:t>7/25/26</a:t>
             </a:fld>
             <a:endParaRPr lang="en-US"/>
           </a:p>
@@ -3080,7 +3075,7 @@
 </file>
 
 <file path=ppt/slides/slide1.xml><?xml version="1.0" encoding="utf-8"?>
-<p:sld xmlns:a="http://schemas.openxmlformats.org/drawingml/2006/main" xmlns:p="http://schemas.openxmlformats.org/presentationml/2006/main" xmlns:r="http://schemas.openxmlformats.org/officeDocument/2006/relationships">
+<p:sld xmlns:a="http://schemas.openxmlformats.org/drawingml/2006/main" xmlns:r="http://schemas.openxmlformats.org/officeDocument/2006/relationships" xmlns:p="http://schemas.openxmlformats.org/presentationml/2006/main">
   <p:cSld>
     <p:spTree>
       <p:nvGrpSpPr>
@@ -3088,7 +3083,14 @@
         <p:cNvGrpSpPr/>
         <p:nvPr/>
       </p:nvGrpSpPr>
-      <p:grpSpPr/>
+      <p:grpSpPr>
+        <a:xfrm>
+          <a:off x="0" y="0"/>
+          <a:ext cx="0" cy="0"/>
+          <a:chOff x="0" y="0"/>
+          <a:chExt cx="0" cy="0"/>
+        </a:xfrm>
+      </p:grpSpPr>
       <p:sp>
         <p:nvSpPr>
           <p:cNvPr id="2" name="Rectangle 1"/>
@@ -3130,6 +3132,7 @@
           <a:lstStyle/>
           <a:p>
             <a:pPr algn="ctr"/>
+            <a:endParaRPr/>
           </a:p>
         </p:txBody>
       </p:sp>
@@ -3174,6 +3177,7 @@
           <a:lstStyle/>
           <a:p>
             <a:pPr algn="ctr"/>
+            <a:endParaRPr/>
           </a:p>
         </p:txBody>
       </p:sp>
@@ -3218,6 +3222,7 @@
           <a:lstStyle/>
           <a:p>
             <a:pPr algn="ctr"/>
+            <a:endParaRPr/>
           </a:p>
         </p:txBody>
       </p:sp>
@@ -3264,6 +3269,7 @@
           <a:lstStyle/>
           <a:p>
             <a:pPr algn="ctr"/>
+            <a:endParaRPr/>
           </a:p>
         </p:txBody>
       </p:sp>
@@ -3284,7 +3290,7 @@
           <a:noFill/>
         </p:spPr>
         <p:txBody>
-          <a:bodyPr wrap="square" anchor="ctr" lIns="0" rIns="0" tIns="0" bIns="0">
+          <a:bodyPr wrap="square" lIns="0" tIns="0" rIns="0" bIns="0" anchor="ctr">
             <a:spAutoFit/>
           </a:bodyPr>
           <a:lstStyle/>
@@ -3329,7 +3335,7 @@
           <a:noFill/>
         </p:spPr>
         <p:txBody>
-          <a:bodyPr wrap="square" anchor="t" lIns="0" rIns="0" tIns="0" bIns="0">
+          <a:bodyPr wrap="square" lIns="0" tIns="0" rIns="0" bIns="0" anchor="t">
             <a:spAutoFit/>
           </a:bodyPr>
           <a:lstStyle/>
@@ -3374,7 +3380,7 @@
           <a:noFill/>
         </p:spPr>
         <p:txBody>
-          <a:bodyPr wrap="square" anchor="t" lIns="0" rIns="0" tIns="0" bIns="0">
+          <a:bodyPr wrap="square" lIns="0" tIns="0" rIns="0" bIns="0" anchor="t">
             <a:spAutoFit/>
           </a:bodyPr>
           <a:lstStyle/>
@@ -3441,7 +3447,7 @@
           </a:fontRef>
         </p:style>
         <p:txBody>
-          <a:bodyPr rtlCol="0" anchor="ctr" wrap="none" lIns="25400" rIns="25400" tIns="0" bIns="0"/>
+          <a:bodyPr wrap="none" lIns="25400" tIns="0" rIns="25400" bIns="0" rtlCol="0" anchor="ctr"/>
           <a:lstStyle/>
           <a:p>
             <a:pPr algn="ctr"/>
@@ -3500,6 +3506,7 @@
           <a:lstStyle/>
           <a:p>
             <a:pPr algn="ctr"/>
+            <a:endParaRPr/>
           </a:p>
         </p:txBody>
       </p:sp>
@@ -3520,7 +3527,7 @@
           <a:noFill/>
         </p:spPr>
         <p:txBody>
-          <a:bodyPr wrap="square" anchor="ctr" lIns="0" rIns="0" tIns="0" bIns="0">
+          <a:bodyPr wrap="square" lIns="0" tIns="0" rIns="0" bIns="0" anchor="ctr">
             <a:spAutoFit/>
           </a:bodyPr>
           <a:lstStyle/>
@@ -3574,7 +3581,7 @@
           <a:noFill/>
         </p:spPr>
         <p:txBody>
-          <a:bodyPr wrap="square" anchor="t" lIns="0" rIns="0" tIns="0" bIns="0">
+          <a:bodyPr wrap="square" lIns="0" tIns="0" rIns="0" bIns="0" anchor="t">
             <a:spAutoFit/>
           </a:bodyPr>
           <a:lstStyle/>
@@ -3619,7 +3626,7 @@
           <a:noFill/>
         </p:spPr>
         <p:txBody>
-          <a:bodyPr wrap="square" anchor="t" lIns="0" rIns="0" tIns="0" bIns="0">
+          <a:bodyPr wrap="square" lIns="0" tIns="0" rIns="0" bIns="0" anchor="t">
             <a:spAutoFit/>
           </a:bodyPr>
           <a:lstStyle/>
@@ -3664,7 +3671,7 @@
           <a:noFill/>
         </p:spPr>
         <p:txBody>
-          <a:bodyPr wrap="square" anchor="t" lIns="0" rIns="0" tIns="0" bIns="0">
+          <a:bodyPr wrap="square" lIns="0" tIns="0" rIns="0" bIns="0" anchor="t">
             <a:spAutoFit/>
           </a:bodyPr>
           <a:lstStyle/>
@@ -3733,6 +3740,7 @@
           <a:lstStyle/>
           <a:p>
             <a:pPr algn="ctr"/>
+            <a:endParaRPr/>
           </a:p>
         </p:txBody>
       </p:sp>
@@ -3753,7 +3761,7 @@
           <a:noFill/>
         </p:spPr>
         <p:txBody>
-          <a:bodyPr wrap="square" anchor="t" lIns="0" rIns="0" tIns="0" bIns="0">
+          <a:bodyPr wrap="square" lIns="0" tIns="0" rIns="0" bIns="0" anchor="t">
             <a:spAutoFit/>
           </a:bodyPr>
           <a:lstStyle/>
@@ -3831,6 +3839,7 @@
           <a:lstStyle/>
           <a:p>
             <a:pPr algn="ctr"/>
+            <a:endParaRPr/>
           </a:p>
         </p:txBody>
       </p:sp>
@@ -3851,7 +3860,7 @@
           <a:noFill/>
         </p:spPr>
         <p:txBody>
-          <a:bodyPr wrap="square" anchor="t" lIns="0" rIns="0" tIns="0" bIns="0">
+          <a:bodyPr wrap="square" lIns="0" tIns="0" rIns="0" bIns="0" anchor="t">
             <a:spAutoFit/>
           </a:bodyPr>
           <a:lstStyle/>
@@ -3929,6 +3938,7 @@
           <a:lstStyle/>
           <a:p>
             <a:pPr algn="ctr"/>
+            <a:endParaRPr/>
           </a:p>
         </p:txBody>
       </p:sp>
@@ -3949,7 +3959,7 @@
           <a:noFill/>
         </p:spPr>
         <p:txBody>
-          <a:bodyPr wrap="square" anchor="t" lIns="0" rIns="0" tIns="0" bIns="0">
+          <a:bodyPr wrap="square" lIns="0" tIns="0" rIns="0" bIns="0" anchor="t">
             <a:spAutoFit/>
           </a:bodyPr>
           <a:lstStyle/>
@@ -4027,6 +4037,7 @@
           <a:lstStyle/>
           <a:p>
             <a:pPr algn="ctr"/>
+            <a:endParaRPr/>
           </a:p>
         </p:txBody>
       </p:sp>
@@ -4047,7 +4058,7 @@
           <a:noFill/>
         </p:spPr>
         <p:txBody>
-          <a:bodyPr wrap="square" anchor="t" lIns="0" rIns="0" tIns="0" bIns="0">
+          <a:bodyPr wrap="square" lIns="0" tIns="0" rIns="0" bIns="0" anchor="t">
             <a:spAutoFit/>
           </a:bodyPr>
           <a:lstStyle/>
@@ -4129,6 +4140,7 @@
           <a:lstStyle/>
           <a:p>
             <a:pPr algn="ctr"/>
+            <a:endParaRPr/>
           </a:p>
         </p:txBody>
       </p:sp>
@@ -4149,7 +4161,7 @@
           <a:noFill/>
         </p:spPr>
         <p:txBody>
-          <a:bodyPr wrap="square" anchor="t" lIns="0" rIns="0" tIns="0" bIns="0">
+          <a:bodyPr wrap="square" lIns="0" tIns="0" rIns="0" bIns="0" anchor="t">
             <a:spAutoFit/>
           </a:bodyPr>
           <a:lstStyle/>
@@ -4210,7 +4222,7 @@
 </file>
 
 <file path=ppt/slides/slide2.xml><?xml version="1.0" encoding="utf-8"?>
-<p:sld xmlns:a="http://schemas.openxmlformats.org/drawingml/2006/main" xmlns:p="http://schemas.openxmlformats.org/presentationml/2006/main" xmlns:r="http://schemas.openxmlformats.org/officeDocument/2006/relationships">
+<p:sld xmlns:a="http://schemas.openxmlformats.org/drawingml/2006/main" xmlns:r="http://schemas.openxmlformats.org/officeDocument/2006/relationships" xmlns:p="http://schemas.openxmlformats.org/presentationml/2006/main">
   <p:cSld>
     <p:spTree>
       <p:nvGrpSpPr>
@@ -4218,7 +4230,14 @@
         <p:cNvGrpSpPr/>
         <p:nvPr/>
       </p:nvGrpSpPr>
-      <p:grpSpPr/>
+      <p:grpSpPr>
+        <a:xfrm>
+          <a:off x="0" y="0"/>
+          <a:ext cx="0" cy="0"/>
+          <a:chOff x="0" y="0"/>
+          <a:chExt cx="0" cy="0"/>
+        </a:xfrm>
+      </p:grpSpPr>
       <p:sp>
         <p:nvSpPr>
           <p:cNvPr id="2" name="Rectangle 1"/>
@@ -4260,6 +4279,7 @@
           <a:lstStyle/>
           <a:p>
             <a:pPr algn="ctr"/>
+            <a:endParaRPr/>
           </a:p>
         </p:txBody>
       </p:sp>
@@ -4304,6 +4324,7 @@
           <a:lstStyle/>
           <a:p>
             <a:pPr algn="ctr"/>
+            <a:endParaRPr/>
           </a:p>
         </p:txBody>
       </p:sp>
@@ -4348,6 +4369,7 @@
           <a:lstStyle/>
           <a:p>
             <a:pPr algn="ctr"/>
+            <a:endParaRPr/>
           </a:p>
         </p:txBody>
       </p:sp>
@@ -4368,7 +4390,7 @@
           <a:noFill/>
         </p:spPr>
         <p:txBody>
-          <a:bodyPr wrap="square" anchor="t" lIns="0" rIns="0" tIns="0" bIns="0">
+          <a:bodyPr wrap="square" lIns="0" tIns="0" rIns="0" bIns="0" anchor="t">
             <a:spAutoFit/>
           </a:bodyPr>
           <a:lstStyle/>
@@ -4413,7 +4435,7 @@
           <a:noFill/>
         </p:spPr>
         <p:txBody>
-          <a:bodyPr wrap="square" anchor="t" lIns="0" rIns="0" tIns="0" bIns="0">
+          <a:bodyPr wrap="square" lIns="0" tIns="0" rIns="0" bIns="0" anchor="t">
             <a:spAutoFit/>
           </a:bodyPr>
           <a:lstStyle/>
@@ -4480,7 +4502,7 @@
           </a:fontRef>
         </p:style>
         <p:txBody>
-          <a:bodyPr rtlCol="0" anchor="ctr" wrap="none" lIns="25400" rIns="25400" tIns="0" bIns="0"/>
+          <a:bodyPr wrap="none" lIns="25400" tIns="0" rIns="25400" bIns="0" rtlCol="0" anchor="ctr"/>
           <a:lstStyle/>
           <a:p>
             <a:pPr algn="ctr"/>
@@ -4513,7 +4535,7 @@
           <a:noFill/>
         </p:spPr>
         <p:txBody>
-          <a:bodyPr wrap="square" anchor="t" lIns="0" rIns="0" tIns="0" bIns="0">
+          <a:bodyPr wrap="square" lIns="0" tIns="0" rIns="0" bIns="0" anchor="t">
             <a:spAutoFit/>
           </a:bodyPr>
           <a:lstStyle/>
@@ -4582,6 +4604,7 @@
           <a:lstStyle/>
           <a:p>
             <a:pPr algn="ctr"/>
+            <a:endParaRPr/>
           </a:p>
         </p:txBody>
       </p:sp>
@@ -4602,7 +4625,7 @@
           <a:noFill/>
         </p:spPr>
         <p:txBody>
-          <a:bodyPr wrap="square" anchor="ctr" lIns="0" rIns="0" tIns="0" bIns="0">
+          <a:bodyPr wrap="square" lIns="0" tIns="0" rIns="0" bIns="0" anchor="ctr">
             <a:spAutoFit/>
           </a:bodyPr>
           <a:lstStyle/>
@@ -4647,7 +4670,7 @@
           <a:noFill/>
         </p:spPr>
         <p:txBody>
-          <a:bodyPr wrap="square" anchor="ctr" lIns="0" rIns="0" tIns="0" bIns="0">
+          <a:bodyPr wrap="square" lIns="0" tIns="0" rIns="0" bIns="0" anchor="ctr">
             <a:spAutoFit/>
           </a:bodyPr>
           <a:lstStyle/>
@@ -4692,7 +4715,7 @@
           <a:noFill/>
         </p:spPr>
         <p:txBody>
-          <a:bodyPr wrap="square" anchor="ctr" lIns="0" rIns="0" tIns="0" bIns="0">
+          <a:bodyPr wrap="square" lIns="0" tIns="0" rIns="0" bIns="0" anchor="ctr">
             <a:spAutoFit/>
           </a:bodyPr>
           <a:lstStyle/>
@@ -4737,7 +4760,7 @@
           <a:noFill/>
         </p:spPr>
         <p:txBody>
-          <a:bodyPr wrap="square" anchor="ctr" lIns="0" rIns="0" tIns="0" bIns="0">
+          <a:bodyPr wrap="square" lIns="0" tIns="0" rIns="0" bIns="0" anchor="ctr">
             <a:spAutoFit/>
           </a:bodyPr>
           <a:lstStyle/>
@@ -4782,7 +4805,7 @@
           <a:noFill/>
         </p:spPr>
         <p:txBody>
-          <a:bodyPr wrap="square" anchor="ctr" lIns="0" rIns="0" tIns="0" bIns="0">
+          <a:bodyPr wrap="square" lIns="0" tIns="0" rIns="0" bIns="0" anchor="ctr">
             <a:spAutoFit/>
           </a:bodyPr>
           <a:lstStyle/>
@@ -4851,6 +4874,7 @@
           <a:lstStyle/>
           <a:p>
             <a:pPr algn="ctr"/>
+            <a:endParaRPr/>
           </a:p>
         </p:txBody>
       </p:sp>
@@ -4893,7 +4917,7 @@
           </a:fontRef>
         </p:style>
         <p:txBody>
-          <a:bodyPr rtlCol="0" anchor="ctr" wrap="none" lIns="25400" rIns="25400" tIns="0" bIns="0"/>
+          <a:bodyPr wrap="none" lIns="25400" tIns="0" rIns="25400" bIns="0" rtlCol="0" anchor="ctr"/>
           <a:lstStyle/>
           <a:p>
             <a:pPr algn="ctr"/>
@@ -4926,7 +4950,7 @@
           <a:noFill/>
         </p:spPr>
         <p:txBody>
-          <a:bodyPr wrap="square" anchor="ctr" lIns="0" rIns="0" tIns="0" bIns="0">
+          <a:bodyPr wrap="square" lIns="0" tIns="0" rIns="0" bIns="0" anchor="ctr">
             <a:spAutoFit/>
           </a:bodyPr>
           <a:lstStyle/>
@@ -4971,7 +4995,7 @@
           <a:noFill/>
         </p:spPr>
         <p:txBody>
-          <a:bodyPr wrap="square" anchor="ctr" lIns="0" rIns="0" tIns="0" bIns="0">
+          <a:bodyPr wrap="square" lIns="0" tIns="0" rIns="0" bIns="0" anchor="ctr">
             <a:spAutoFit/>
           </a:bodyPr>
           <a:lstStyle/>
@@ -5016,7 +5040,7 @@
           <a:noFill/>
         </p:spPr>
         <p:txBody>
-          <a:bodyPr wrap="square" anchor="ctr" lIns="0" rIns="0" tIns="0" bIns="0">
+          <a:bodyPr wrap="square" lIns="0" tIns="0" rIns="0" bIns="0" anchor="ctr">
             <a:spAutoFit/>
           </a:bodyPr>
           <a:lstStyle/>
@@ -5061,7 +5085,7 @@
           <a:noFill/>
         </p:spPr>
         <p:txBody>
-          <a:bodyPr wrap="square" anchor="ctr" lIns="0" rIns="0" tIns="0" bIns="0">
+          <a:bodyPr wrap="square" lIns="0" tIns="0" rIns="0" bIns="0" anchor="ctr">
             <a:spAutoFit/>
           </a:bodyPr>
           <a:lstStyle/>
@@ -5130,6 +5154,7 @@
           <a:lstStyle/>
           <a:p>
             <a:pPr algn="ctr"/>
+            <a:endParaRPr/>
           </a:p>
         </p:txBody>
       </p:sp>
@@ -5174,6 +5199,7 @@
           <a:lstStyle/>
           <a:p>
             <a:pPr algn="ctr"/>
+            <a:endParaRPr/>
           </a:p>
         </p:txBody>
       </p:sp>
@@ -5216,7 +5242,7 @@
           </a:fontRef>
         </p:style>
         <p:txBody>
-          <a:bodyPr rtlCol="0" anchor="ctr" wrap="none" lIns="25400" rIns="25400" tIns="0" bIns="0"/>
+          <a:bodyPr wrap="none" lIns="25400" tIns="0" rIns="25400" bIns="0" rtlCol="0" anchor="ctr"/>
           <a:lstStyle/>
           <a:p>
             <a:pPr algn="ctr"/>
@@ -5249,7 +5275,7 @@
           <a:noFill/>
         </p:spPr>
         <p:txBody>
-          <a:bodyPr wrap="square" anchor="ctr" lIns="0" rIns="0" tIns="0" bIns="0">
+          <a:bodyPr wrap="square" lIns="0" tIns="0" rIns="0" bIns="0" anchor="ctr">
             <a:spAutoFit/>
           </a:bodyPr>
           <a:lstStyle/>
@@ -5294,7 +5320,7 @@
           <a:noFill/>
         </p:spPr>
         <p:txBody>
-          <a:bodyPr wrap="square" anchor="ctr" lIns="0" rIns="0" tIns="0" bIns="0">
+          <a:bodyPr wrap="square" lIns="0" tIns="0" rIns="0" bIns="0" anchor="ctr">
             <a:spAutoFit/>
           </a:bodyPr>
           <a:lstStyle/>
@@ -5339,7 +5365,7 @@
           <a:noFill/>
         </p:spPr>
         <p:txBody>
-          <a:bodyPr wrap="square" anchor="ctr" lIns="0" rIns="0" tIns="0" bIns="0">
+          <a:bodyPr wrap="square" lIns="0" tIns="0" rIns="0" bIns="0" anchor="ctr">
             <a:spAutoFit/>
           </a:bodyPr>
           <a:lstStyle/>
@@ -5384,7 +5410,7 @@
           <a:noFill/>
         </p:spPr>
         <p:txBody>
-          <a:bodyPr wrap="square" anchor="ctr" lIns="0" rIns="0" tIns="0" bIns="0">
+          <a:bodyPr wrap="square" lIns="0" tIns="0" rIns="0" bIns="0" anchor="ctr">
             <a:spAutoFit/>
           </a:bodyPr>
           <a:lstStyle/>
@@ -5453,6 +5479,7 @@
           <a:lstStyle/>
           <a:p>
             <a:pPr algn="ctr"/>
+            <a:endParaRPr/>
           </a:p>
         </p:txBody>
       </p:sp>
@@ -5497,6 +5524,7 @@
           <a:lstStyle/>
           <a:p>
             <a:pPr algn="ctr"/>
+            <a:endParaRPr/>
           </a:p>
         </p:txBody>
       </p:sp>
@@ -5539,7 +5567,7 @@
           </a:fontRef>
         </p:style>
         <p:txBody>
-          <a:bodyPr rtlCol="0" anchor="ctr" wrap="none" lIns="25400" rIns="25400" tIns="0" bIns="0"/>
+          <a:bodyPr wrap="none" lIns="25400" tIns="0" rIns="25400" bIns="0" rtlCol="0" anchor="ctr"/>
           <a:lstStyle/>
           <a:p>
             <a:pPr algn="ctr"/>
@@ -5572,7 +5600,7 @@
           <a:noFill/>
         </p:spPr>
         <p:txBody>
-          <a:bodyPr wrap="square" anchor="ctr" lIns="0" rIns="0" tIns="0" bIns="0">
+          <a:bodyPr wrap="square" lIns="0" tIns="0" rIns="0" bIns="0" anchor="ctr">
             <a:spAutoFit/>
           </a:bodyPr>
           <a:lstStyle/>
@@ -5617,7 +5645,7 @@
           <a:noFill/>
         </p:spPr>
         <p:txBody>
-          <a:bodyPr wrap="square" anchor="ctr" lIns="0" rIns="0" tIns="0" bIns="0">
+          <a:bodyPr wrap="square" lIns="0" tIns="0" rIns="0" bIns="0" anchor="ctr">
             <a:spAutoFit/>
           </a:bodyPr>
           <a:lstStyle/>
@@ -5662,7 +5690,7 @@
           <a:noFill/>
         </p:spPr>
         <p:txBody>
-          <a:bodyPr wrap="square" anchor="ctr" lIns="0" rIns="0" tIns="0" bIns="0">
+          <a:bodyPr wrap="square" lIns="0" tIns="0" rIns="0" bIns="0" anchor="ctr">
             <a:spAutoFit/>
           </a:bodyPr>
           <a:lstStyle/>
@@ -5707,7 +5735,7 @@
           <a:noFill/>
         </p:spPr>
         <p:txBody>
-          <a:bodyPr wrap="square" anchor="ctr" lIns="0" rIns="0" tIns="0" bIns="0">
+          <a:bodyPr wrap="square" lIns="0" tIns="0" rIns="0" bIns="0" anchor="ctr">
             <a:spAutoFit/>
           </a:bodyPr>
           <a:lstStyle/>
@@ -5776,6 +5804,7 @@
           <a:lstStyle/>
           <a:p>
             <a:pPr algn="ctr"/>
+            <a:endParaRPr/>
           </a:p>
         </p:txBody>
       </p:sp>
@@ -5820,6 +5849,7 @@
           <a:lstStyle/>
           <a:p>
             <a:pPr algn="ctr"/>
+            <a:endParaRPr/>
           </a:p>
         </p:txBody>
       </p:sp>
@@ -5862,7 +5892,7 @@
           </a:fontRef>
         </p:style>
         <p:txBody>
-          <a:bodyPr rtlCol="0" anchor="ctr" wrap="none" lIns="25400" rIns="25400" tIns="0" bIns="0"/>
+          <a:bodyPr wrap="none" lIns="25400" tIns="0" rIns="25400" bIns="0" rtlCol="0" anchor="ctr"/>
           <a:lstStyle/>
           <a:p>
             <a:pPr algn="ctr"/>
@@ -5895,7 +5925,7 @@
           <a:noFill/>
         </p:spPr>
         <p:txBody>
-          <a:bodyPr wrap="square" anchor="ctr" lIns="0" rIns="0" tIns="0" bIns="0">
+          <a:bodyPr wrap="square" lIns="0" tIns="0" rIns="0" bIns="0" anchor="ctr">
             <a:spAutoFit/>
           </a:bodyPr>
           <a:lstStyle/>
@@ -5940,7 +5970,7 @@
           <a:noFill/>
         </p:spPr>
         <p:txBody>
-          <a:bodyPr wrap="square" anchor="ctr" lIns="0" rIns="0" tIns="0" bIns="0">
+          <a:bodyPr wrap="square" lIns="0" tIns="0" rIns="0" bIns="0" anchor="ctr">
             <a:spAutoFit/>
           </a:bodyPr>
           <a:lstStyle/>
@@ -5985,7 +6015,7 @@
           <a:noFill/>
         </p:spPr>
         <p:txBody>
-          <a:bodyPr wrap="square" anchor="ctr" lIns="0" rIns="0" tIns="0" bIns="0">
+          <a:bodyPr wrap="square" lIns="0" tIns="0" rIns="0" bIns="0" anchor="ctr">
             <a:spAutoFit/>
           </a:bodyPr>
           <a:lstStyle/>
@@ -6030,7 +6060,7 @@
           <a:noFill/>
         </p:spPr>
         <p:txBody>
-          <a:bodyPr wrap="square" anchor="ctr" lIns="0" rIns="0" tIns="0" bIns="0">
+          <a:bodyPr wrap="square" lIns="0" tIns="0" rIns="0" bIns="0" anchor="ctr">
             <a:spAutoFit/>
           </a:bodyPr>
           <a:lstStyle/>
@@ -6099,6 +6129,7 @@
           <a:lstStyle/>
           <a:p>
             <a:pPr algn="ctr"/>
+            <a:endParaRPr/>
           </a:p>
         </p:txBody>
       </p:sp>
@@ -6143,6 +6174,7 @@
           <a:lstStyle/>
           <a:p>
             <a:pPr algn="ctr"/>
+            <a:endParaRPr/>
           </a:p>
         </p:txBody>
       </p:sp>
@@ -6185,7 +6217,7 @@
           </a:fontRef>
         </p:style>
         <p:txBody>
-          <a:bodyPr rtlCol="0" anchor="ctr" wrap="none" lIns="25400" rIns="25400" tIns="0" bIns="0"/>
+          <a:bodyPr wrap="none" lIns="25400" tIns="0" rIns="25400" bIns="0" rtlCol="0" anchor="ctr"/>
           <a:lstStyle/>
           <a:p>
             <a:pPr algn="ctr"/>
@@ -6218,7 +6250,7 @@
           <a:noFill/>
         </p:spPr>
         <p:txBody>
-          <a:bodyPr wrap="square" anchor="ctr" lIns="0" rIns="0" tIns="0" bIns="0">
+          <a:bodyPr wrap="square" lIns="0" tIns="0" rIns="0" bIns="0" anchor="ctr">
             <a:spAutoFit/>
           </a:bodyPr>
           <a:lstStyle/>
@@ -6263,7 +6295,7 @@
           <a:noFill/>
         </p:spPr>
         <p:txBody>
-          <a:bodyPr wrap="square" anchor="ctr" lIns="0" rIns="0" tIns="0" bIns="0">
+          <a:bodyPr wrap="square" lIns="0" tIns="0" rIns="0" bIns="0" anchor="ctr">
             <a:spAutoFit/>
           </a:bodyPr>
           <a:lstStyle/>
@@ -6308,7 +6340,7 @@
           <a:noFill/>
         </p:spPr>
         <p:txBody>
-          <a:bodyPr wrap="square" anchor="ctr" lIns="0" rIns="0" tIns="0" bIns="0">
+          <a:bodyPr wrap="square" lIns="0" tIns="0" rIns="0" bIns="0" anchor="ctr">
             <a:spAutoFit/>
           </a:bodyPr>
           <a:lstStyle/>
@@ -6353,7 +6385,7 @@
           <a:noFill/>
         </p:spPr>
         <p:txBody>
-          <a:bodyPr wrap="square" anchor="ctr" lIns="0" rIns="0" tIns="0" bIns="0">
+          <a:bodyPr wrap="square" lIns="0" tIns="0" rIns="0" bIns="0" anchor="ctr">
             <a:spAutoFit/>
           </a:bodyPr>
           <a:lstStyle/>
@@ -6422,6 +6454,7 @@
           <a:lstStyle/>
           <a:p>
             <a:pPr algn="ctr"/>
+            <a:endParaRPr/>
           </a:p>
         </p:txBody>
       </p:sp>
@@ -6466,6 +6499,7 @@
           <a:lstStyle/>
           <a:p>
             <a:pPr algn="ctr"/>
+            <a:endParaRPr/>
           </a:p>
         </p:txBody>
       </p:sp>
@@ -6508,7 +6542,7 @@
           </a:fontRef>
         </p:style>
         <p:txBody>
-          <a:bodyPr rtlCol="0" anchor="ctr" wrap="none" lIns="25400" rIns="25400" tIns="0" bIns="0"/>
+          <a:bodyPr wrap="none" lIns="25400" tIns="0" rIns="25400" bIns="0" rtlCol="0" anchor="ctr"/>
           <a:lstStyle/>
           <a:p>
             <a:pPr algn="ctr"/>
@@ -6541,7 +6575,7 @@
           <a:noFill/>
         </p:spPr>
         <p:txBody>
-          <a:bodyPr wrap="square" anchor="ctr" lIns="0" rIns="0" tIns="0" bIns="0">
+          <a:bodyPr wrap="square" lIns="0" tIns="0" rIns="0" bIns="0" anchor="ctr">
             <a:spAutoFit/>
           </a:bodyPr>
           <a:lstStyle/>
@@ -6586,7 +6620,7 @@
           <a:noFill/>
         </p:spPr>
         <p:txBody>
-          <a:bodyPr wrap="square" anchor="ctr" lIns="0" rIns="0" tIns="0" bIns="0">
+          <a:bodyPr wrap="square" lIns="0" tIns="0" rIns="0" bIns="0" anchor="ctr">
             <a:spAutoFit/>
           </a:bodyPr>
           <a:lstStyle/>
@@ -6631,7 +6665,7 @@
           <a:noFill/>
         </p:spPr>
         <p:txBody>
-          <a:bodyPr wrap="square" anchor="ctr" lIns="0" rIns="0" tIns="0" bIns="0">
+          <a:bodyPr wrap="square" lIns="0" tIns="0" rIns="0" bIns="0" anchor="ctr">
             <a:spAutoFit/>
           </a:bodyPr>
           <a:lstStyle/>
@@ -6676,7 +6710,7 @@
           <a:noFill/>
         </p:spPr>
         <p:txBody>
-          <a:bodyPr wrap="square" anchor="ctr" lIns="0" rIns="0" tIns="0" bIns="0">
+          <a:bodyPr wrap="square" lIns="0" tIns="0" rIns="0" bIns="0" anchor="ctr">
             <a:spAutoFit/>
           </a:bodyPr>
           <a:lstStyle/>
@@ -6745,6 +6779,7 @@
           <a:lstStyle/>
           <a:p>
             <a:pPr algn="ctr"/>
+            <a:endParaRPr/>
           </a:p>
         </p:txBody>
       </p:sp>
@@ -6789,6 +6824,7 @@
           <a:lstStyle/>
           <a:p>
             <a:pPr algn="ctr"/>
+            <a:endParaRPr/>
           </a:p>
         </p:txBody>
       </p:sp>
@@ -6831,7 +6867,7 @@
           </a:fontRef>
         </p:style>
         <p:txBody>
-          <a:bodyPr rtlCol="0" anchor="ctr" wrap="none" lIns="25400" rIns="25400" tIns="0" bIns="0"/>
+          <a:bodyPr wrap="none" lIns="25400" tIns="0" rIns="25400" bIns="0" rtlCol="0" anchor="ctr"/>
           <a:lstStyle/>
           <a:p>
             <a:pPr algn="ctr"/>
@@ -6864,7 +6900,7 @@
           <a:noFill/>
         </p:spPr>
         <p:txBody>
-          <a:bodyPr wrap="square" anchor="ctr" lIns="0" rIns="0" tIns="0" bIns="0">
+          <a:bodyPr wrap="square" lIns="0" tIns="0" rIns="0" bIns="0" anchor="ctr">
             <a:spAutoFit/>
           </a:bodyPr>
           <a:lstStyle/>
@@ -6909,7 +6945,7 @@
           <a:noFill/>
         </p:spPr>
         <p:txBody>
-          <a:bodyPr wrap="square" anchor="ctr" lIns="0" rIns="0" tIns="0" bIns="0">
+          <a:bodyPr wrap="square" lIns="0" tIns="0" rIns="0" bIns="0" anchor="ctr">
             <a:spAutoFit/>
           </a:bodyPr>
           <a:lstStyle/>
@@ -6954,7 +6990,7 @@
           <a:noFill/>
         </p:spPr>
         <p:txBody>
-          <a:bodyPr wrap="square" anchor="ctr" lIns="0" rIns="0" tIns="0" bIns="0">
+          <a:bodyPr wrap="square" lIns="0" tIns="0" rIns="0" bIns="0" anchor="ctr">
             <a:spAutoFit/>
           </a:bodyPr>
           <a:lstStyle/>
@@ -6999,7 +7035,7 @@
           <a:noFill/>
         </p:spPr>
         <p:txBody>
-          <a:bodyPr wrap="square" anchor="ctr" lIns="0" rIns="0" tIns="0" bIns="0">
+          <a:bodyPr wrap="square" lIns="0" tIns="0" rIns="0" bIns="0" anchor="ctr">
             <a:spAutoFit/>
           </a:bodyPr>
           <a:lstStyle/>
@@ -7068,6 +7104,7 @@
           <a:lstStyle/>
           <a:p>
             <a:pPr algn="ctr"/>
+            <a:endParaRPr/>
           </a:p>
         </p:txBody>
       </p:sp>
@@ -7112,6 +7149,7 @@
           <a:lstStyle/>
           <a:p>
             <a:pPr algn="ctr"/>
+            <a:endParaRPr/>
           </a:p>
         </p:txBody>
       </p:sp>
@@ -7154,7 +7192,7 @@
           </a:fontRef>
         </p:style>
         <p:txBody>
-          <a:bodyPr rtlCol="0" anchor="ctr" wrap="none" lIns="25400" rIns="25400" tIns="0" bIns="0"/>
+          <a:bodyPr wrap="none" lIns="25400" tIns="0" rIns="25400" bIns="0" rtlCol="0" anchor="ctr"/>
           <a:lstStyle/>
           <a:p>
             <a:pPr algn="ctr"/>
@@ -7187,7 +7225,7 @@
           <a:noFill/>
         </p:spPr>
         <p:txBody>
-          <a:bodyPr wrap="square" anchor="ctr" lIns="0" rIns="0" tIns="0" bIns="0">
+          <a:bodyPr wrap="square" lIns="0" tIns="0" rIns="0" bIns="0" anchor="ctr">
             <a:spAutoFit/>
           </a:bodyPr>
           <a:lstStyle/>
@@ -7232,7 +7270,7 @@
           <a:noFill/>
         </p:spPr>
         <p:txBody>
-          <a:bodyPr wrap="square" anchor="ctr" lIns="0" rIns="0" tIns="0" bIns="0">
+          <a:bodyPr wrap="square" lIns="0" tIns="0" rIns="0" bIns="0" anchor="ctr">
             <a:spAutoFit/>
           </a:bodyPr>
           <a:lstStyle/>
@@ -7277,7 +7315,7 @@
           <a:noFill/>
         </p:spPr>
         <p:txBody>
-          <a:bodyPr wrap="square" anchor="ctr" lIns="0" rIns="0" tIns="0" bIns="0">
+          <a:bodyPr wrap="square" lIns="0" tIns="0" rIns="0" bIns="0" anchor="ctr">
             <a:spAutoFit/>
           </a:bodyPr>
           <a:lstStyle/>
@@ -7322,7 +7360,7 @@
           <a:noFill/>
         </p:spPr>
         <p:txBody>
-          <a:bodyPr wrap="square" anchor="ctr" lIns="0" rIns="0" tIns="0" bIns="0">
+          <a:bodyPr wrap="square" lIns="0" tIns="0" rIns="0" bIns="0" anchor="ctr">
             <a:spAutoFit/>
           </a:bodyPr>
           <a:lstStyle/>
@@ -7391,6 +7429,7 @@
           <a:lstStyle/>
           <a:p>
             <a:pPr algn="ctr"/>
+            <a:endParaRPr/>
           </a:p>
         </p:txBody>
       </p:sp>
@@ -7435,6 +7474,7 @@
           <a:lstStyle/>
           <a:p>
             <a:pPr algn="ctr"/>
+            <a:endParaRPr/>
           </a:p>
         </p:txBody>
       </p:sp>
@@ -7477,7 +7517,7 @@
           </a:fontRef>
         </p:style>
         <p:txBody>
-          <a:bodyPr rtlCol="0" anchor="ctr" wrap="none" lIns="25400" rIns="25400" tIns="0" bIns="0"/>
+          <a:bodyPr wrap="none" lIns="25400" tIns="0" rIns="25400" bIns="0" rtlCol="0" anchor="ctr"/>
           <a:lstStyle/>
           <a:p>
             <a:pPr algn="ctr"/>
@@ -7510,7 +7550,7 @@
           <a:noFill/>
         </p:spPr>
         <p:txBody>
-          <a:bodyPr wrap="square" anchor="ctr" lIns="0" rIns="0" tIns="0" bIns="0">
+          <a:bodyPr wrap="square" lIns="0" tIns="0" rIns="0" bIns="0" anchor="ctr">
             <a:spAutoFit/>
           </a:bodyPr>
           <a:lstStyle/>
@@ -7555,7 +7595,7 @@
           <a:noFill/>
         </p:spPr>
         <p:txBody>
-          <a:bodyPr wrap="square" anchor="ctr" lIns="0" rIns="0" tIns="0" bIns="0">
+          <a:bodyPr wrap="square" lIns="0" tIns="0" rIns="0" bIns="0" anchor="ctr">
             <a:spAutoFit/>
           </a:bodyPr>
           <a:lstStyle/>
@@ -7600,7 +7640,7 @@
           <a:noFill/>
         </p:spPr>
         <p:txBody>
-          <a:bodyPr wrap="square" anchor="ctr" lIns="0" rIns="0" tIns="0" bIns="0">
+          <a:bodyPr wrap="square" lIns="0" tIns="0" rIns="0" bIns="0" anchor="ctr">
             <a:spAutoFit/>
           </a:bodyPr>
           <a:lstStyle/>
@@ -7645,7 +7685,7 @@
           <a:noFill/>
         </p:spPr>
         <p:txBody>
-          <a:bodyPr wrap="square" anchor="ctr" lIns="0" rIns="0" tIns="0" bIns="0">
+          <a:bodyPr wrap="square" lIns="0" tIns="0" rIns="0" bIns="0" anchor="ctr">
             <a:spAutoFit/>
           </a:bodyPr>
           <a:lstStyle/>
@@ -7714,6 +7754,7 @@
           <a:lstStyle/>
           <a:p>
             <a:pPr algn="ctr"/>
+            <a:endParaRPr/>
           </a:p>
         </p:txBody>
       </p:sp>
@@ -7758,6 +7799,7 @@
           <a:lstStyle/>
           <a:p>
             <a:pPr algn="ctr"/>
+            <a:endParaRPr/>
           </a:p>
         </p:txBody>
       </p:sp>
@@ -7800,7 +7842,7 @@
           </a:fontRef>
         </p:style>
         <p:txBody>
-          <a:bodyPr rtlCol="0" anchor="ctr" wrap="none" lIns="25400" rIns="25400" tIns="0" bIns="0"/>
+          <a:bodyPr wrap="none" lIns="25400" tIns="0" rIns="25400" bIns="0" rtlCol="0" anchor="ctr"/>
           <a:lstStyle/>
           <a:p>
             <a:pPr algn="ctr"/>
@@ -7833,7 +7875,7 @@
           <a:noFill/>
         </p:spPr>
         <p:txBody>
-          <a:bodyPr wrap="square" anchor="ctr" lIns="0" rIns="0" tIns="0" bIns="0">
+          <a:bodyPr wrap="square" lIns="0" tIns="0" rIns="0" bIns="0" anchor="ctr">
             <a:spAutoFit/>
           </a:bodyPr>
           <a:lstStyle/>
@@ -7878,7 +7920,7 @@
           <a:noFill/>
         </p:spPr>
         <p:txBody>
-          <a:bodyPr wrap="square" anchor="ctr" lIns="0" rIns="0" tIns="0" bIns="0">
+          <a:bodyPr wrap="square" lIns="0" tIns="0" rIns="0" bIns="0" anchor="ctr">
             <a:spAutoFit/>
           </a:bodyPr>
           <a:lstStyle/>
@@ -7923,7 +7965,7 @@
           <a:noFill/>
         </p:spPr>
         <p:txBody>
-          <a:bodyPr wrap="square" anchor="ctr" lIns="0" rIns="0" tIns="0" bIns="0">
+          <a:bodyPr wrap="square" lIns="0" tIns="0" rIns="0" bIns="0" anchor="ctr">
             <a:spAutoFit/>
           </a:bodyPr>
           <a:lstStyle/>
@@ -7968,7 +8010,7 @@
           <a:noFill/>
         </p:spPr>
         <p:txBody>
-          <a:bodyPr wrap="square" anchor="ctr" lIns="0" rIns="0" tIns="0" bIns="0">
+          <a:bodyPr wrap="square" lIns="0" tIns="0" rIns="0" bIns="0" anchor="ctr">
             <a:spAutoFit/>
           </a:bodyPr>
           <a:lstStyle/>
@@ -8037,6 +8079,7 @@
           <a:lstStyle/>
           <a:p>
             <a:pPr algn="ctr"/>
+            <a:endParaRPr/>
           </a:p>
         </p:txBody>
       </p:sp>
@@ -8083,6 +8126,7 @@
           <a:lstStyle/>
           <a:p>
             <a:pPr algn="ctr"/>
+            <a:endParaRPr/>
           </a:p>
         </p:txBody>
       </p:sp>
@@ -8095,7 +8139,7 @@
         <p:spPr>
           <a:xfrm>
             <a:off x="667512" y="5283403"/>
-            <a:ext cx="7141464" cy="548640"/>
+            <a:ext cx="7141464" cy="355097"/>
           </a:xfrm>
           <a:prstGeom prst="rect">
             <a:avLst/>
@@ -8103,7 +8147,7 @@
           <a:noFill/>
         </p:spPr>
         <p:txBody>
-          <a:bodyPr wrap="square" anchor="t" lIns="0" rIns="0" tIns="0" bIns="0">
+          <a:bodyPr wrap="square" lIns="0" tIns="0" rIns="0" bIns="0" anchor="t">
             <a:spAutoFit/>
           </a:bodyPr>
           <a:lstStyle/>
@@ -8120,7 +8164,7 @@
               </a:spcAft>
             </a:pPr>
             <a:r>
-              <a:rPr sz="1000" b="1">
+              <a:rPr sz="1000" b="1" dirty="0">
                 <a:solidFill>
                   <a:srgbClr val="2E6FB0"/>
                 </a:solidFill>
@@ -8129,13 +8173,49 @@
               <a:t>Cross-cutting:   </a:t>
             </a:r>
             <a:r>
-              <a:rPr sz="1000" b="0">
+              <a:rPr sz="1000" b="0" dirty="0">
                 <a:solidFill>
                   <a:srgbClr val="1A2733"/>
                 </a:solidFill>
                 <a:latin typeface="Calibri"/>
               </a:rPr>
-              <a:t>Cloud — AWS Amplify Hosting (S3 + CloudFront) · ECS on Fargate · RDS for PostgreSQL · S3 · Secrets Manager</a:t>
+              <a:t>Cloud — AWS </a:t>
+            </a:r>
+            <a:r>
+              <a:rPr lang="en-US" sz="1000" b="0" dirty="0">
+                <a:solidFill>
+                  <a:srgbClr val="1A2733"/>
+                </a:solidFill>
+                <a:latin typeface="Calibri"/>
+              </a:rPr>
+              <a:t>infra </a:t>
+            </a:r>
+            <a:r>
+              <a:rPr lang="en-US" sz="1000" b="0">
+                <a:solidFill>
+                  <a:srgbClr val="1A2733"/>
+                </a:solidFill>
+                <a:latin typeface="Calibri"/>
+              </a:rPr>
+              <a:t>with Terraform </a:t>
+            </a:r>
+            <a:r>
+              <a:rPr sz="1000" b="0">
+                <a:solidFill>
+                  <a:srgbClr val="1A2733"/>
+                </a:solidFill>
+                <a:latin typeface="Calibri"/>
+              </a:rPr>
+              <a:t>· </a:t>
+            </a:r>
+            <a:r>
+              <a:rPr sz="1000" b="0" dirty="0">
+                <a:solidFill>
+                  <a:srgbClr val="1A2733"/>
+                </a:solidFill>
+                <a:latin typeface="Calibri"/>
+              </a:rPr>
+              <a:t>ECS on Fargate · RDS for PostgreSQL · S3 · Secrets Manager</a:t>
             </a:r>
           </a:p>
           <a:p>
@@ -8151,16 +8231,25 @@
               </a:spcAft>
             </a:pPr>
             <a:r>
-              <a:rPr sz="1000" b="1">
+              <a:rPr sz="1000" b="1" dirty="0" err="1">
                 <a:solidFill>
                   <a:srgbClr val="2E6FB0"/>
                 </a:solidFill>
                 <a:latin typeface="Calibri"/>
               </a:rPr>
-              <a:t>DevSecOps — </a:t>
-            </a:r>
-            <a:r>
-              <a:rPr sz="1000" b="0">
+              <a:t>DevSecOps</a:t>
+            </a:r>
+            <a:r>
+              <a:rPr sz="1000" b="1" dirty="0">
+                <a:solidFill>
+                  <a:srgbClr val="2E6FB0"/>
+                </a:solidFill>
+                <a:latin typeface="Calibri"/>
+              </a:rPr>
+              <a:t> — </a:t>
+            </a:r>
+            <a:r>
+              <a:rPr sz="1000" b="0" dirty="0">
                 <a:solidFill>
                   <a:srgbClr val="1A2733"/>
                 </a:solidFill>
@@ -8188,7 +8277,7 @@
           <a:noFill/>
         </p:spPr>
         <p:txBody>
-          <a:bodyPr wrap="square" anchor="t" lIns="0" rIns="0" tIns="0" bIns="0">
+          <a:bodyPr wrap="square" lIns="0" tIns="0" rIns="0" bIns="0" anchor="t">
             <a:spAutoFit/>
           </a:bodyPr>
           <a:lstStyle/>
@@ -8259,6 +8348,7 @@
           <a:lstStyle/>
           <a:p>
             <a:pPr algn="ctr"/>
+            <a:endParaRPr/>
           </a:p>
         </p:txBody>
       </p:sp>
@@ -8303,7 +8393,7 @@
           <a:noFill/>
         </p:spPr>
         <p:txBody>
-          <a:bodyPr wrap="square" anchor="t" lIns="0" rIns="0" tIns="0" bIns="0">
+          <a:bodyPr wrap="square" lIns="0" tIns="0" rIns="0" bIns="0" anchor="t">
             <a:spAutoFit/>
           </a:bodyPr>
           <a:lstStyle/>
@@ -8374,6 +8464,7 @@
           <a:lstStyle/>
           <a:p>
             <a:pPr algn="ctr"/>
+            <a:endParaRPr/>
           </a:p>
         </p:txBody>
       </p:sp>
@@ -8418,7 +8509,7 @@
           <a:noFill/>
         </p:spPr>
         <p:txBody>
-          <a:bodyPr wrap="square" anchor="t" lIns="0" rIns="0" tIns="0" bIns="0">
+          <a:bodyPr wrap="square" lIns="0" tIns="0" rIns="0" bIns="0" anchor="t">
             <a:spAutoFit/>
           </a:bodyPr>
           <a:lstStyle/>
@@ -8489,6 +8580,7 @@
           <a:lstStyle/>
           <a:p>
             <a:pPr algn="ctr"/>
+            <a:endParaRPr/>
           </a:p>
         </p:txBody>
       </p:sp>
@@ -8533,7 +8625,7 @@
           <a:noFill/>
         </p:spPr>
         <p:txBody>
-          <a:bodyPr wrap="square" anchor="t" lIns="0" rIns="0" tIns="0" bIns="0">
+          <a:bodyPr wrap="square" lIns="0" tIns="0" rIns="0" bIns="0" anchor="t">
             <a:spAutoFit/>
           </a:bodyPr>
           <a:lstStyle/>
@@ -8604,6 +8696,7 @@
           <a:lstStyle/>
           <a:p>
             <a:pPr algn="ctr"/>
+            <a:endParaRPr/>
           </a:p>
         </p:txBody>
       </p:sp>
@@ -8648,7 +8741,7 @@
           <a:noFill/>
         </p:spPr>
         <p:txBody>
-          <a:bodyPr wrap="square" anchor="t" lIns="0" rIns="0" tIns="0" bIns="0">
+          <a:bodyPr wrap="square" lIns="0" tIns="0" rIns="0" bIns="0" anchor="t">
             <a:spAutoFit/>
           </a:bodyPr>
           <a:lstStyle/>

</xml_diff>